<commit_message>
Update report/deck: temporal test + 3-method amount spread
</commit_message>
<xml_diff>
--- a/deck/LSOG_Mapping_Uncertainty_Deck.pptx
+++ b/deck/LSOG_Mapping_Uncertainty_Deck.pptx
@@ -16,9 +16,11 @@
     <p:sldId id="264" r:id="rId10"/>
     <p:sldId id="265" r:id="rId11"/>
     <p:sldId id="266" r:id="rId12"/>
+    <p:sldId id="267" r:id="rId13"/>
+    <p:sldId id="268" r:id="rId14"/>
   </p:sldIdLst>
   <p:notesMasterIdLst>
-    <p:notesMasterId r:id="rId13"/>
+    <p:notesMasterId r:id="rId15"/>
   </p:notesMasterIdLst>
   <p:sldSz cx="12188952" cy="6858000"/>
   <p:notesSz cx="6858000" cy="12188952"/>
@@ -712,6 +714,182 @@
             <a:fld id="{F7021451-1387-4CA6-816F-3879F97B5CBC}" type="slidenum">
               <a:rPr lang="en-US"/>
               <a:t>11</a:t>
+            </a:fld>
+            <a:endParaRPr lang="en-US"/>
+          </a:p>
+        </p:txBody>
+      </p:sp>
+    </p:spTree>
+    <p:extLst>
+      <p:ext uri="{BB962C8B-B14F-4D97-AF65-F5344CB8AC3E}">
+        <p14:creationId xmlns:p14="http://schemas.microsoft.com/office/powerpoint/2010/main" val="1024086991"/>
+      </p:ext>
+    </p:extLst>
+  </p:cSld>
+  <p:clrMapOvr>
+    <a:masterClrMapping/>
+  </p:clrMapOvr>
+</p:notes>
+</file>
+
+<file path=ppt/notesSlides/notesSlide12.xml><?xml version="1.0" encoding="utf-8"?>
+<p:notes xmlns:a="http://schemas.openxmlformats.org/drawingml/2006/main" xmlns:r="http://schemas.openxmlformats.org/officeDocument/2006/relationships" xmlns:p="http://schemas.openxmlformats.org/presentationml/2006/main">
+  <p:cSld>
+    <p:spTree>
+      <p:nvGrpSpPr>
+        <p:cNvPr id="1" name=""/>
+        <p:cNvGrpSpPr/>
+        <p:nvPr/>
+      </p:nvGrpSpPr>
+      <p:grpSpPr>
+        <a:xfrm>
+          <a:off x="0" y="0"/>
+          <a:ext cx="0" cy="0"/>
+          <a:chOff x="0" y="0"/>
+          <a:chExt cx="0" cy="0"/>
+        </a:xfrm>
+      </p:grpSpPr>
+      <p:sp>
+        <p:nvSpPr>
+          <p:cNvPr id="2" name="Slide Image Placeholder 1"/>
+          <p:cNvSpPr>
+            <a:spLocks noGrp="1" noRot="1" noChangeAspect="1"/>
+          </p:cNvSpPr>
+          <p:nvPr>
+            <p:ph type="sldImg"/>
+          </p:nvPr>
+        </p:nvSpPr>
+        <p:spPr/>
+      </p:sp>
+      <p:sp>
+        <p:nvSpPr>
+          <p:cNvPr id="3" name="Notes Placeholder 2"/>
+          <p:cNvSpPr>
+            <a:spLocks noGrp="1"/>
+          </p:cNvSpPr>
+          <p:nvPr>
+            <p:ph type="body" idx="1"/>
+          </p:nvPr>
+        </p:nvSpPr>
+        <p:spPr/>
+        <p:txBody>
+          <a:bodyPr/>
+          <a:lstStyle/>
+          <a:p>
+            <a:r>
+              <a:rPr lang="en-US" dirty="0"/>
+              <a:t/>
+            </a:r>
+            <a:endParaRPr lang="en-US" dirty="0"/>
+          </a:p>
+        </p:txBody>
+      </p:sp>
+      <p:sp>
+        <p:nvSpPr>
+          <p:cNvPr id="4" name="Slide Number Placeholder 3"/>
+          <p:cNvSpPr>
+            <a:spLocks noGrp="1"/>
+          </p:cNvSpPr>
+          <p:nvPr>
+            <p:ph type="sldNum" sz="quarter" idx="10"/>
+          </p:nvPr>
+        </p:nvSpPr>
+        <p:spPr/>
+        <p:txBody>
+          <a:bodyPr/>
+          <a:lstStyle/>
+          <a:p>
+            <a:fld id="{F7021451-1387-4CA6-816F-3879F97B5CBC}" type="slidenum">
+              <a:rPr lang="en-US"/>
+              <a:t>12</a:t>
+            </a:fld>
+            <a:endParaRPr lang="en-US"/>
+          </a:p>
+        </p:txBody>
+      </p:sp>
+    </p:spTree>
+    <p:extLst>
+      <p:ext uri="{BB962C8B-B14F-4D97-AF65-F5344CB8AC3E}">
+        <p14:creationId xmlns:p14="http://schemas.microsoft.com/office/powerpoint/2010/main" val="1024086991"/>
+      </p:ext>
+    </p:extLst>
+  </p:cSld>
+  <p:clrMapOvr>
+    <a:masterClrMapping/>
+  </p:clrMapOvr>
+</p:notes>
+</file>
+
+<file path=ppt/notesSlides/notesSlide13.xml><?xml version="1.0" encoding="utf-8"?>
+<p:notes xmlns:a="http://schemas.openxmlformats.org/drawingml/2006/main" xmlns:r="http://schemas.openxmlformats.org/officeDocument/2006/relationships" xmlns:p="http://schemas.openxmlformats.org/presentationml/2006/main">
+  <p:cSld>
+    <p:spTree>
+      <p:nvGrpSpPr>
+        <p:cNvPr id="1" name=""/>
+        <p:cNvGrpSpPr/>
+        <p:nvPr/>
+      </p:nvGrpSpPr>
+      <p:grpSpPr>
+        <a:xfrm>
+          <a:off x="0" y="0"/>
+          <a:ext cx="0" cy="0"/>
+          <a:chOff x="0" y="0"/>
+          <a:chExt cx="0" cy="0"/>
+        </a:xfrm>
+      </p:grpSpPr>
+      <p:sp>
+        <p:nvSpPr>
+          <p:cNvPr id="2" name="Slide Image Placeholder 1"/>
+          <p:cNvSpPr>
+            <a:spLocks noGrp="1" noRot="1" noChangeAspect="1"/>
+          </p:cNvSpPr>
+          <p:nvPr>
+            <p:ph type="sldImg"/>
+          </p:nvPr>
+        </p:nvSpPr>
+        <p:spPr/>
+      </p:sp>
+      <p:sp>
+        <p:nvSpPr>
+          <p:cNvPr id="3" name="Notes Placeholder 2"/>
+          <p:cNvSpPr>
+            <a:spLocks noGrp="1"/>
+          </p:cNvSpPr>
+          <p:nvPr>
+            <p:ph type="body" idx="1"/>
+          </p:nvPr>
+        </p:nvSpPr>
+        <p:spPr/>
+        <p:txBody>
+          <a:bodyPr/>
+          <a:lstStyle/>
+          <a:p>
+            <a:r>
+              <a:rPr lang="en-US" dirty="0"/>
+              <a:t/>
+            </a:r>
+            <a:endParaRPr lang="en-US" dirty="0"/>
+          </a:p>
+        </p:txBody>
+      </p:sp>
+      <p:sp>
+        <p:nvSpPr>
+          <p:cNvPr id="4" name="Slide Number Placeholder 3"/>
+          <p:cNvSpPr>
+            <a:spLocks noGrp="1"/>
+          </p:cNvSpPr>
+          <p:nvPr>
+            <p:ph type="sldNum" sz="quarter" idx="10"/>
+          </p:nvPr>
+        </p:nvSpPr>
+        <p:spPr/>
+        <p:txBody>
+          <a:bodyPr/>
+          <a:lstStyle/>
+          <a:p>
+            <a:fld id="{F7021451-1387-4CA6-816F-3879F97B5CBC}" type="slidenum">
+              <a:rPr lang="en-US"/>
+              <a:t>13</a:t>
             </a:fld>
             <a:endParaRPr lang="en-US"/>
           </a:p>
@@ -1979,42 +2157,46 @@
                 <a:ea typeface="Aptos Display" pitchFamily="34" charset="-122"/>
                 <a:cs typeface="Aptos Display" pitchFamily="34" charset="-120"/>
               </a:rPr>
-              <a:t>What to do</a:t>
+              <a:t>A third method widens the disagreement</a:t>
             </a:r>
             <a:endParaRPr lang="en-US" sz="2900" dirty="0"/>
           </a:p>
         </p:txBody>
       </p:sp>
-      <p:sp>
-        <p:nvSpPr>
-          <p:cNvPr id="3" name="Shape 1"/>
-          <p:cNvSpPr/>
-          <p:nvPr/>
-        </p:nvSpPr>
-        <p:spPr>
-          <a:xfrm>
-            <a:off x="731520" y="1627632"/>
-            <a:ext cx="146304" cy="146304"/>
-          </a:xfrm>
-          <a:prstGeom prst="rect">
-            <a:avLst/>
-          </a:prstGeom>
-          <a:solidFill>
-            <a:srgbClr val="C5A55A"/>
-          </a:solidFill>
-          <a:ln/>
-        </p:spPr>
-      </p:sp>
-      <p:sp>
-        <p:nvSpPr>
-          <p:cNvPr id="4" name="Text 2"/>
-          <p:cNvSpPr/>
-          <p:nvPr/>
-        </p:nvSpPr>
-        <p:spPr>
-          <a:xfrm>
-            <a:off x="1097280" y="1444752"/>
-            <a:ext cx="10424160" cy="868680"/>
+      <p:pic>
+        <p:nvPicPr>
+          <p:cNvPr id="3" name="Image 0" descr="figs/u_spread3.png">    </p:cNvPr>
+          <p:cNvPicPr>
+            <a:picLocks noChangeAspect="1"/>
+          </p:cNvPicPr>
+          <p:nvPr/>
+        </p:nvPicPr>
+        <p:blipFill>
+          <a:blip r:embed="rId1"/>
+          <a:stretch>
+            <a:fillRect/>
+          </a:stretch>
+        </p:blipFill>
+        <p:spPr>
+          <a:xfrm>
+            <a:off x="1828800" y="1371600"/>
+            <a:ext cx="6583680" cy="4023360"/>
+          </a:xfrm>
+          <a:prstGeom prst="rect">
+            <a:avLst/>
+          </a:prstGeom>
+        </p:spPr>
+      </p:pic>
+      <p:sp>
+        <p:nvSpPr>
+          <p:cNvPr id="4" name="Text 1"/>
+          <p:cNvSpPr/>
+          <p:nvPr/>
+        </p:nvSpPr>
+        <p:spPr>
+          <a:xfrm>
+            <a:off x="8686800" y="1920240"/>
+            <a:ext cx="3108960" cy="3108960"/>
           </a:xfrm>
           <a:prstGeom prst="rect">
             <a:avLst/>
@@ -2030,7 +2212,27 @@
               <a:buNone/>
             </a:pPr>
             <a:r>
-              <a:rPr lang="en-US" sz="1800" dirty="0">
+              <a:rPr lang="en-US" sz="4800" b="1" dirty="0">
+                <a:solidFill>
+                  <a:srgbClr val="B22234"/>
+                </a:solidFill>
+                <a:latin typeface="Aptos Display" pitchFamily="34" charset="0"/>
+                <a:ea typeface="Aptos Display" pitchFamily="34" charset="-122"/>
+                <a:cs typeface="Aptos Display" pitchFamily="34" charset="-120"/>
+              </a:rPr>
+              <a:t>2.8×</a:t>
+            </a:r>
+            <a:pPr indent="0" marL="0">
+              <a:buNone/>
+            </a:pPr>
+            <a:endParaRPr lang="en-US" sz="4800" dirty="0"/>
+          </a:p>
+          <a:p>
+            <a:pPr indent="0" marL="0">
+              <a:buNone/>
+            </a:pPr>
+            <a:r>
+              <a:rPr lang="en-US" sz="1700" dirty="0">
                 <a:solidFill>
                   <a:srgbClr val="333333"/>
                 </a:solidFill>
@@ -2038,58 +2240,16 @@
                 <a:ea typeface="Aptos" pitchFamily="34" charset="-122"/>
                 <a:cs typeface="Aptos" pitchFamily="34" charset="-120"/>
               </a:rPr>
-              <a:t>Report LSOG extent as a range across methods with explicit uncertainty, not one number</a:t>
-            </a:r>
-            <a:endParaRPr lang="en-US" sz="1800" dirty="0"/>
-          </a:p>
-        </p:txBody>
-      </p:sp>
-      <p:sp>
-        <p:nvSpPr>
-          <p:cNvPr id="5" name="Shape 3"/>
-          <p:cNvSpPr/>
-          <p:nvPr/>
-        </p:nvSpPr>
-        <p:spPr>
-          <a:xfrm>
-            <a:off x="731520" y="2679192"/>
-            <a:ext cx="146304" cy="146304"/>
-          </a:xfrm>
-          <a:prstGeom prst="rect">
-            <a:avLst/>
-          </a:prstGeom>
-          <a:solidFill>
-            <a:srgbClr val="C5A55A"/>
-          </a:solidFill>
-          <a:ln/>
-        </p:spPr>
-      </p:sp>
-      <p:sp>
-        <p:nvSpPr>
-          <p:cNvPr id="6" name="Text 4"/>
-          <p:cNvSpPr/>
-          <p:nvPr/>
-        </p:nvSpPr>
-        <p:spPr>
-          <a:xfrm>
-            <a:off x="1097280" y="2496312"/>
-            <a:ext cx="10424160" cy="868680"/>
-          </a:xfrm>
-          <a:prstGeom prst="rect">
-            <a:avLst/>
-          </a:prstGeom>
-          <a:noFill/>
-          <a:ln/>
-        </p:spPr>
-        <p:txBody>
-          <a:bodyPr wrap="square" rtlCol="0" anchor="ctr"/>
-          <a:lstStyle/>
-          <a:p>
-            <a:pPr indent="0" marL="0">
-              <a:buNone/>
-            </a:pPr>
-            <a:r>
-              <a:rPr lang="en-US" sz="1800" dirty="0">
+              <a:t>spread in “how much</a:t>
+            </a:r>
+            <a:endParaRPr lang="en-US" sz="4800" dirty="0"/>
+          </a:p>
+          <a:p>
+            <a:pPr indent="0" marL="0">
+              <a:buNone/>
+            </a:pPr>
+            <a:r>
+              <a:rPr lang="en-US" sz="1700" dirty="0">
                 <a:solidFill>
                   <a:srgbClr val="333333"/>
                 </a:solidFill>
@@ -2097,58 +2257,16 @@
                 <a:ea typeface="Aptos" pitchFamily="34" charset="-122"/>
                 <a:cs typeface="Aptos" pitchFamily="34" charset="-120"/>
               </a:rPr>
-              <a:t>Treat single-map patch-level prioritization for large spending with caution; field-verify before acquisition</a:t>
-            </a:r>
-            <a:endParaRPr lang="en-US" sz="1800" dirty="0"/>
-          </a:p>
-        </p:txBody>
-      </p:sp>
-      <p:sp>
-        <p:nvSpPr>
-          <p:cNvPr id="7" name="Shape 5"/>
-          <p:cNvSpPr/>
-          <p:nvPr/>
-        </p:nvSpPr>
-        <p:spPr>
-          <a:xfrm>
-            <a:off x="731520" y="3730752"/>
-            <a:ext cx="146304" cy="146304"/>
-          </a:xfrm>
-          <a:prstGeom prst="rect">
-            <a:avLst/>
-          </a:prstGeom>
-          <a:solidFill>
-            <a:srgbClr val="C5A55A"/>
-          </a:solidFill>
-          <a:ln/>
-        </p:spPr>
-      </p:sp>
-      <p:sp>
-        <p:nvSpPr>
-          <p:cNvPr id="8" name="Text 6"/>
-          <p:cNvSpPr/>
-          <p:nvPr/>
-        </p:nvSpPr>
-        <p:spPr>
-          <a:xfrm>
-            <a:off x="1097280" y="3547872"/>
-            <a:ext cx="10424160" cy="868680"/>
-          </a:xfrm>
-          <a:prstGeom prst="rect">
-            <a:avLst/>
-          </a:prstGeom>
-          <a:noFill/>
-          <a:ln/>
-        </p:spPr>
-        <p:txBody>
-          <a:bodyPr wrap="square" rtlCol="0" anchor="ctr"/>
-          <a:lstStyle/>
-          <a:p>
-            <a:pPr indent="0" marL="0">
-              <a:buNone/>
-            </a:pPr>
-            <a:r>
-              <a:rPr lang="en-US" sz="1800" dirty="0">
+              <a:t>LSOG” across three</a:t>
+            </a:r>
+            <a:endParaRPr lang="en-US" sz="4800" dirty="0"/>
+          </a:p>
+          <a:p>
+            <a:pPr indent="0" marL="0">
+              <a:buNone/>
+            </a:pPr>
+            <a:r>
+              <a:rPr lang="en-US" sz="1700" dirty="0">
                 <a:solidFill>
                   <a:srgbClr val="333333"/>
                 </a:solidFill>
@@ -2156,58 +2274,16 @@
                 <a:ea typeface="Aptos" pitchFamily="34" charset="-122"/>
                 <a:cs typeface="Aptos" pitchFamily="34" charset="-120"/>
               </a:rPr>
-              <a:t>Anchor the mappable definition in FIA field structure (v5.1) with GEDI height as predictor — most defensible, still one estimate</a:t>
-            </a:r>
-            <a:endParaRPr lang="en-US" sz="1800" dirty="0"/>
-          </a:p>
-        </p:txBody>
-      </p:sp>
-      <p:sp>
-        <p:nvSpPr>
-          <p:cNvPr id="9" name="Shape 7"/>
-          <p:cNvSpPr/>
-          <p:nvPr/>
-        </p:nvSpPr>
-        <p:spPr>
-          <a:xfrm>
-            <a:off x="731520" y="4782312"/>
-            <a:ext cx="146304" cy="146304"/>
-          </a:xfrm>
-          <a:prstGeom prst="rect">
-            <a:avLst/>
-          </a:prstGeom>
-          <a:solidFill>
-            <a:srgbClr val="C5A55A"/>
-          </a:solidFill>
-          <a:ln/>
-        </p:spPr>
-      </p:sp>
-      <p:sp>
-        <p:nvSpPr>
-          <p:cNvPr id="10" name="Text 8"/>
-          <p:cNvSpPr/>
-          <p:nvPr/>
-        </p:nvSpPr>
-        <p:spPr>
-          <a:xfrm>
-            <a:off x="1097280" y="4599432"/>
-            <a:ext cx="10424160" cy="868680"/>
-          </a:xfrm>
-          <a:prstGeom prst="rect">
-            <a:avLst/>
-          </a:prstGeom>
-          <a:noFill/>
-          <a:ln/>
-        </p:spPr>
-        <p:txBody>
-          <a:bodyPr wrap="square" rtlCol="0" anchor="ctr"/>
-          <a:lstStyle/>
-          <a:p>
-            <a:pPr indent="0" marL="0">
-              <a:buNone/>
-            </a:pPr>
-            <a:r>
-              <a:rPr lang="en-US" sz="1800" dirty="0">
+              <a:t>credible methods</a:t>
+            </a:r>
+            <a:endParaRPr lang="en-US" sz="4800" dirty="0"/>
+          </a:p>
+          <a:p>
+            <a:pPr indent="0" marL="0">
+              <a:buNone/>
+            </a:pPr>
+            <a:r>
+              <a:rPr lang="en-US" sz="1700" dirty="0">
                 <a:solidFill>
                   <a:srgbClr val="333333"/>
                 </a:solidFill>
@@ -2215,15 +2291,15 @@
                 <a:ea typeface="Aptos" pitchFamily="34" charset="-122"/>
                 <a:cs typeface="Aptos" pitchFamily="34" charset="-120"/>
               </a:rPr>
-              <a:t>Reports informing LD 1529 should carry the mapping uncertainty in the headline, not the appendix</a:t>
-            </a:r>
-            <a:endParaRPr lang="en-US" sz="1800" dirty="0"/>
-          </a:p>
-        </p:txBody>
-      </p:sp>
-      <p:sp>
-        <p:nvSpPr>
-          <p:cNvPr id="11" name="Shape 9"/>
+              <a:t>(7.8% to 21.9%)</a:t>
+            </a:r>
+            <a:endParaRPr lang="en-US" sz="4800" dirty="0"/>
+          </a:p>
+        </p:txBody>
+      </p:sp>
+      <p:sp>
+        <p:nvSpPr>
+          <p:cNvPr id="5" name="Shape 2"/>
           <p:cNvSpPr/>
           <p:nvPr/>
         </p:nvSpPr>
@@ -2243,7 +2319,7 @@
       </p:sp>
       <p:sp>
         <p:nvSpPr>
-          <p:cNvPr id="12" name="Text 10"/>
+          <p:cNvPr id="6" name="Text 3"/>
           <p:cNvSpPr/>
           <p:nvPr/>
         </p:nvSpPr>
@@ -2274,7 +2350,7 @@
                 <a:ea typeface="Aptos" pitchFamily="34" charset="-122"/>
                 <a:cs typeface="Aptos" pitchFamily="34" charset="-120"/>
               </a:rPr>
-              <a:t>Use the maps as uncertain guidance, not as precise spending blueprints</a:t>
+              <a:t>The more methods we add, the wider the uncertainty, not the narrower</a:t>
             </a:r>
             <a:endParaRPr lang="en-US" sz="1700" dirty="0"/>
           </a:p>
@@ -2291,6 +2367,722 @@
 <file path=ppt/slides/slide11.xml><?xml version="1.0" encoding="utf-8"?>
 <p:sld xmlns:a="http://schemas.openxmlformats.org/drawingml/2006/main" xmlns:r="http://schemas.openxmlformats.org/officeDocument/2006/relationships" xmlns:p="http://schemas.openxmlformats.org/presentationml/2006/main">
   <p:cSld name="Slide 11">
+    <p:spTree>
+      <p:nvGrpSpPr>
+        <p:cNvPr id="1" name=""/>
+        <p:cNvGrpSpPr/>
+        <p:nvPr/>
+      </p:nvGrpSpPr>
+      <p:grpSpPr>
+        <a:xfrm>
+          <a:off x="0" y="0"/>
+          <a:ext cx="0" cy="0"/>
+          <a:chOff x="0" y="0"/>
+          <a:chExt cx="0" cy="0"/>
+        </a:xfrm>
+      </p:grpSpPr>
+      <p:sp>
+        <p:nvSpPr>
+          <p:cNvPr id="2" name="Text 0"/>
+          <p:cNvSpPr/>
+          <p:nvPr/>
+        </p:nvSpPr>
+        <p:spPr>
+          <a:xfrm>
+            <a:off x="548640" y="320040"/>
+            <a:ext cx="11064240" cy="822960"/>
+          </a:xfrm>
+          <a:prstGeom prst="rect">
+            <a:avLst/>
+          </a:prstGeom>
+          <a:noFill/>
+          <a:ln/>
+        </p:spPr>
+        <p:txBody>
+          <a:bodyPr wrap="square" rtlCol="0" anchor="ctr"/>
+          <a:lstStyle/>
+          <a:p>
+            <a:pPr indent="0" marL="0">
+              <a:buNone/>
+            </a:pPr>
+            <a:r>
+              <a:rPr lang="en-US" sz="2900" b="1" dirty="0">
+                <a:solidFill>
+                  <a:srgbClr val="333333"/>
+                </a:solidFill>
+                <a:latin typeface="Aptos Display" pitchFamily="34" charset="0"/>
+                <a:ea typeface="Aptos Display" pitchFamily="34" charset="-122"/>
+                <a:cs typeface="Aptos Display" pitchFamily="34" charset="-120"/>
+              </a:rPr>
+              <a:t>This is real disagreement, not a reproduction error</a:t>
+            </a:r>
+            <a:endParaRPr lang="en-US" sz="2900" dirty="0"/>
+          </a:p>
+        </p:txBody>
+      </p:sp>
+      <p:sp>
+        <p:nvSpPr>
+          <p:cNvPr id="3" name="Text 1"/>
+          <p:cNvSpPr/>
+          <p:nvPr/>
+        </p:nvSpPr>
+        <p:spPr>
+          <a:xfrm>
+            <a:off x="914400" y="2194560"/>
+            <a:ext cx="3291840" cy="914400"/>
+          </a:xfrm>
+          <a:prstGeom prst="rect">
+            <a:avLst/>
+          </a:prstGeom>
+          <a:noFill/>
+          <a:ln/>
+        </p:spPr>
+        <p:txBody>
+          <a:bodyPr wrap="square" rtlCol="0" anchor="ctr"/>
+          <a:lstStyle/>
+          <a:p>
+            <a:pPr algn="ctr" indent="0" marL="0">
+              <a:buNone/>
+            </a:pPr>
+            <a:r>
+              <a:rPr lang="en-US" sz="3000" b="1" dirty="0">
+                <a:solidFill>
+                  <a:srgbClr val="1A3D28"/>
+                </a:solidFill>
+                <a:latin typeface="Aptos Display" pitchFamily="34" charset="0"/>
+                <a:ea typeface="Aptos Display" pitchFamily="34" charset="-122"/>
+                <a:cs typeface="Aptos Display" pitchFamily="34" charset="-120"/>
+              </a:rPr>
+              <a:t>94.2% vs 94.1%</a:t>
+            </a:r>
+            <a:endParaRPr lang="en-US" sz="3000" dirty="0"/>
+          </a:p>
+        </p:txBody>
+      </p:sp>
+      <p:sp>
+        <p:nvSpPr>
+          <p:cNvPr id="4" name="Text 2"/>
+          <p:cNvSpPr/>
+          <p:nvPr/>
+        </p:nvSpPr>
+        <p:spPr>
+          <a:xfrm>
+            <a:off x="914400" y="3200400"/>
+            <a:ext cx="3291840" cy="914400"/>
+          </a:xfrm>
+          <a:prstGeom prst="rect">
+            <a:avLst/>
+          </a:prstGeom>
+          <a:noFill/>
+          <a:ln/>
+        </p:spPr>
+        <p:txBody>
+          <a:bodyPr wrap="square" rtlCol="0" anchor="ctr"/>
+          <a:lstStyle/>
+          <a:p>
+            <a:pPr algn="ctr" indent="0" marL="0">
+              <a:buNone/>
+            </a:pPr>
+            <a:r>
+              <a:rPr lang="en-US" sz="1600" dirty="0">
+                <a:solidFill>
+                  <a:srgbClr val="666666"/>
+                </a:solidFill>
+                <a:latin typeface="Aptos" pitchFamily="34" charset="0"/>
+                <a:ea typeface="Aptos" pitchFamily="34" charset="-122"/>
+                <a:cs typeface="Aptos" pitchFamily="34" charset="-120"/>
+              </a:rPr>
+              <a:t>we reproduced Hagan’s model exactly</a:t>
+            </a:r>
+            <a:endParaRPr lang="en-US" sz="1600" dirty="0"/>
+          </a:p>
+        </p:txBody>
+      </p:sp>
+      <p:sp>
+        <p:nvSpPr>
+          <p:cNvPr id="5" name="Text 3"/>
+          <p:cNvSpPr/>
+          <p:nvPr/>
+        </p:nvSpPr>
+        <p:spPr>
+          <a:xfrm>
+            <a:off x="4572000" y="2194560"/>
+            <a:ext cx="3291840" cy="914400"/>
+          </a:xfrm>
+          <a:prstGeom prst="rect">
+            <a:avLst/>
+          </a:prstGeom>
+          <a:noFill/>
+          <a:ln/>
+        </p:spPr>
+        <p:txBody>
+          <a:bodyPr wrap="square" rtlCol="0" anchor="ctr"/>
+          <a:lstStyle/>
+          <a:p>
+            <a:pPr algn="ctr" indent="0" marL="0">
+              <a:buNone/>
+            </a:pPr>
+            <a:r>
+              <a:rPr lang="en-US" sz="3000" b="1" dirty="0">
+                <a:solidFill>
+                  <a:srgbClr val="1A3D28"/>
+                </a:solidFill>
+                <a:latin typeface="Aptos Display" pitchFamily="34" charset="0"/>
+                <a:ea typeface="Aptos Display" pitchFamily="34" charset="-122"/>
+                <a:cs typeface="Aptos Display" pitchFamily="34" charset="-120"/>
+              </a:rPr>
+              <a:t>kappa 0.97</a:t>
+            </a:r>
+            <a:endParaRPr lang="en-US" sz="3000" dirty="0"/>
+          </a:p>
+        </p:txBody>
+      </p:sp>
+      <p:sp>
+        <p:nvSpPr>
+          <p:cNvPr id="6" name="Text 4"/>
+          <p:cNvSpPr/>
+          <p:nvPr/>
+        </p:nvSpPr>
+        <p:spPr>
+          <a:xfrm>
+            <a:off x="4572000" y="3200400"/>
+            <a:ext cx="3291840" cy="914400"/>
+          </a:xfrm>
+          <a:prstGeom prst="rect">
+            <a:avLst/>
+          </a:prstGeom>
+          <a:noFill/>
+          <a:ln/>
+        </p:spPr>
+        <p:txBody>
+          <a:bodyPr wrap="square" rtlCol="0" anchor="ctr"/>
+          <a:lstStyle/>
+          <a:p>
+            <a:pPr algn="ctr" indent="0" marL="0">
+              <a:buNone/>
+            </a:pPr>
+            <a:r>
+              <a:rPr lang="en-US" sz="1600" dirty="0">
+                <a:solidFill>
+                  <a:srgbClr val="666666"/>
+                </a:solidFill>
+                <a:latin typeface="Aptos" pitchFamily="34" charset="0"/>
+                <a:ea typeface="Aptos" pitchFamily="34" charset="-122"/>
+                <a:cs typeface="Aptos" pitchFamily="34" charset="-120"/>
+              </a:rPr>
+              <a:t>Seven Islands raster equals the published model</a:t>
+            </a:r>
+            <a:endParaRPr lang="en-US" sz="1600" dirty="0"/>
+          </a:p>
+        </p:txBody>
+      </p:sp>
+      <p:sp>
+        <p:nvSpPr>
+          <p:cNvPr id="7" name="Text 5"/>
+          <p:cNvSpPr/>
+          <p:nvPr/>
+        </p:nvSpPr>
+        <p:spPr>
+          <a:xfrm>
+            <a:off x="8229600" y="2194560"/>
+            <a:ext cx="3291840" cy="914400"/>
+          </a:xfrm>
+          <a:prstGeom prst="rect">
+            <a:avLst/>
+          </a:prstGeom>
+          <a:noFill/>
+          <a:ln/>
+        </p:spPr>
+        <p:txBody>
+          <a:bodyPr wrap="square" rtlCol="0" anchor="ctr"/>
+          <a:lstStyle/>
+          <a:p>
+            <a:pPr algn="ctr" indent="0" marL="0">
+              <a:buNone/>
+            </a:pPr>
+            <a:r>
+              <a:rPr lang="en-US" sz="3000" b="1" dirty="0">
+                <a:solidFill>
+                  <a:srgbClr val="1A3D28"/>
+                </a:solidFill>
+                <a:latin typeface="Aptos Display" pitchFamily="34" charset="0"/>
+                <a:ea typeface="Aptos Display" pitchFamily="34" charset="-122"/>
+                <a:cs typeface="Aptos Display" pitchFamily="34" charset="-120"/>
+              </a:rPr>
+              <a:t>robust</a:t>
+            </a:r>
+            <a:endParaRPr lang="en-US" sz="3000" dirty="0"/>
+          </a:p>
+        </p:txBody>
+      </p:sp>
+      <p:sp>
+        <p:nvSpPr>
+          <p:cNvPr id="8" name="Text 6"/>
+          <p:cNvSpPr/>
+          <p:nvPr/>
+        </p:nvSpPr>
+        <p:spPr>
+          <a:xfrm>
+            <a:off x="8229600" y="3200400"/>
+            <a:ext cx="3291840" cy="914400"/>
+          </a:xfrm>
+          <a:prstGeom prst="rect">
+            <a:avLst/>
+          </a:prstGeom>
+          <a:noFill/>
+          <a:ln/>
+        </p:spPr>
+        <p:txBody>
+          <a:bodyPr wrap="square" rtlCol="0" anchor="ctr"/>
+          <a:lstStyle/>
+          <a:p>
+            <a:pPr algn="ctr" indent="0" marL="0">
+              <a:buNone/>
+            </a:pPr>
+            <a:r>
+              <a:rPr lang="en-US" sz="1600" dirty="0">
+                <a:solidFill>
+                  <a:srgbClr val="666666"/>
+                </a:solidFill>
+                <a:latin typeface="Aptos" pitchFamily="34" charset="0"/>
+                <a:ea typeface="Aptos" pitchFamily="34" charset="-122"/>
+                <a:cs typeface="Aptos" pitchFamily="34" charset="-120"/>
+              </a:rPr>
+              <a:t>20-seed, fuzz, and bootstrap checks all hold</a:t>
+            </a:r>
+            <a:endParaRPr lang="en-US" sz="1600" dirty="0"/>
+          </a:p>
+        </p:txBody>
+      </p:sp>
+      <p:sp>
+        <p:nvSpPr>
+          <p:cNvPr id="9" name="Shape 7"/>
+          <p:cNvSpPr/>
+          <p:nvPr/>
+        </p:nvSpPr>
+        <p:spPr>
+          <a:xfrm>
+            <a:off x="0" y="6263640"/>
+            <a:ext cx="12188952" cy="594360"/>
+          </a:xfrm>
+          <a:prstGeom prst="rect">
+            <a:avLst/>
+          </a:prstGeom>
+          <a:solidFill>
+            <a:srgbClr val="1A3D28"/>
+          </a:solidFill>
+          <a:ln/>
+        </p:spPr>
+      </p:sp>
+      <p:sp>
+        <p:nvSpPr>
+          <p:cNvPr id="10" name="Text 8"/>
+          <p:cNvSpPr/>
+          <p:nvPr/>
+        </p:nvSpPr>
+        <p:spPr>
+          <a:xfrm>
+            <a:off x="457200" y="6263640"/>
+            <a:ext cx="11247120" cy="594360"/>
+          </a:xfrm>
+          <a:prstGeom prst="rect">
+            <a:avLst/>
+          </a:prstGeom>
+          <a:noFill/>
+          <a:ln/>
+        </p:spPr>
+        <p:txBody>
+          <a:bodyPr wrap="square" rtlCol="0" anchor="ctr"/>
+          <a:lstStyle/>
+          <a:p>
+            <a:pPr indent="0" marL="0">
+              <a:buNone/>
+            </a:pPr>
+            <a:r>
+              <a:rPr lang="en-US" sz="1700" b="1" dirty="0">
+                <a:solidFill>
+                  <a:srgbClr val="FFFFFF"/>
+                </a:solidFill>
+                <a:latin typeface="Aptos" pitchFamily="34" charset="0"/>
+                <a:ea typeface="Aptos" pitchFamily="34" charset="-122"/>
+                <a:cs typeface="Aptos" pitchFamily="34" charset="-120"/>
+              </a:rPr>
+              <a:t>The divergence reflects genuine methodological differences in defining LSOG</a:t>
+            </a:r>
+            <a:endParaRPr lang="en-US" sz="1700" dirty="0"/>
+          </a:p>
+        </p:txBody>
+      </p:sp>
+    </p:spTree>
+  </p:cSld>
+  <p:clrMapOvr>
+    <a:masterClrMapping/>
+  </p:clrMapOvr>
+</p:sld>
+</file>
+
+<file path=ppt/slides/slide12.xml><?xml version="1.0" encoding="utf-8"?>
+<p:sld xmlns:a="http://schemas.openxmlformats.org/drawingml/2006/main" xmlns:r="http://schemas.openxmlformats.org/officeDocument/2006/relationships" xmlns:p="http://schemas.openxmlformats.org/presentationml/2006/main">
+  <p:cSld name="Slide 12">
+    <p:spTree>
+      <p:nvGrpSpPr>
+        <p:cNvPr id="1" name=""/>
+        <p:cNvGrpSpPr/>
+        <p:nvPr/>
+      </p:nvGrpSpPr>
+      <p:grpSpPr>
+        <a:xfrm>
+          <a:off x="0" y="0"/>
+          <a:ext cx="0" cy="0"/>
+          <a:chOff x="0" y="0"/>
+          <a:chExt cx="0" cy="0"/>
+        </a:xfrm>
+      </p:grpSpPr>
+      <p:sp>
+        <p:nvSpPr>
+          <p:cNvPr id="2" name="Text 0"/>
+          <p:cNvSpPr/>
+          <p:nvPr/>
+        </p:nvSpPr>
+        <p:spPr>
+          <a:xfrm>
+            <a:off x="548640" y="320040"/>
+            <a:ext cx="11064240" cy="822960"/>
+          </a:xfrm>
+          <a:prstGeom prst="rect">
+            <a:avLst/>
+          </a:prstGeom>
+          <a:noFill/>
+          <a:ln/>
+        </p:spPr>
+        <p:txBody>
+          <a:bodyPr wrap="square" rtlCol="0" anchor="ctr"/>
+          <a:lstStyle/>
+          <a:p>
+            <a:pPr indent="0" marL="0">
+              <a:buNone/>
+            </a:pPr>
+            <a:r>
+              <a:rPr lang="en-US" sz="2900" b="1" dirty="0">
+                <a:solidFill>
+                  <a:srgbClr val="333333"/>
+                </a:solidFill>
+                <a:latin typeface="Aptos Display" pitchFamily="34" charset="0"/>
+                <a:ea typeface="Aptos Display" pitchFamily="34" charset="-122"/>
+                <a:cs typeface="Aptos Display" pitchFamily="34" charset="-120"/>
+              </a:rPr>
+              <a:t>What to do</a:t>
+            </a:r>
+            <a:endParaRPr lang="en-US" sz="2900" dirty="0"/>
+          </a:p>
+        </p:txBody>
+      </p:sp>
+      <p:sp>
+        <p:nvSpPr>
+          <p:cNvPr id="3" name="Shape 1"/>
+          <p:cNvSpPr/>
+          <p:nvPr/>
+        </p:nvSpPr>
+        <p:spPr>
+          <a:xfrm>
+            <a:off x="731520" y="1627632"/>
+            <a:ext cx="146304" cy="146304"/>
+          </a:xfrm>
+          <a:prstGeom prst="rect">
+            <a:avLst/>
+          </a:prstGeom>
+          <a:solidFill>
+            <a:srgbClr val="C5A55A"/>
+          </a:solidFill>
+          <a:ln/>
+        </p:spPr>
+      </p:sp>
+      <p:sp>
+        <p:nvSpPr>
+          <p:cNvPr id="4" name="Text 2"/>
+          <p:cNvSpPr/>
+          <p:nvPr/>
+        </p:nvSpPr>
+        <p:spPr>
+          <a:xfrm>
+            <a:off x="1097280" y="1444752"/>
+            <a:ext cx="10424160" cy="868680"/>
+          </a:xfrm>
+          <a:prstGeom prst="rect">
+            <a:avLst/>
+          </a:prstGeom>
+          <a:noFill/>
+          <a:ln/>
+        </p:spPr>
+        <p:txBody>
+          <a:bodyPr wrap="square" rtlCol="0" anchor="ctr"/>
+          <a:lstStyle/>
+          <a:p>
+            <a:pPr indent="0" marL="0">
+              <a:buNone/>
+            </a:pPr>
+            <a:r>
+              <a:rPr lang="en-US" sz="1800" dirty="0">
+                <a:solidFill>
+                  <a:srgbClr val="333333"/>
+                </a:solidFill>
+                <a:latin typeface="Aptos" pitchFamily="34" charset="0"/>
+                <a:ea typeface="Aptos" pitchFamily="34" charset="-122"/>
+                <a:cs typeface="Aptos" pitchFamily="34" charset="-120"/>
+              </a:rPr>
+              <a:t>Report LSOG extent as a range across methods with explicit uncertainty, not one number</a:t>
+            </a:r>
+            <a:endParaRPr lang="en-US" sz="1800" dirty="0"/>
+          </a:p>
+        </p:txBody>
+      </p:sp>
+      <p:sp>
+        <p:nvSpPr>
+          <p:cNvPr id="5" name="Shape 3"/>
+          <p:cNvSpPr/>
+          <p:nvPr/>
+        </p:nvSpPr>
+        <p:spPr>
+          <a:xfrm>
+            <a:off x="731520" y="2679192"/>
+            <a:ext cx="146304" cy="146304"/>
+          </a:xfrm>
+          <a:prstGeom prst="rect">
+            <a:avLst/>
+          </a:prstGeom>
+          <a:solidFill>
+            <a:srgbClr val="C5A55A"/>
+          </a:solidFill>
+          <a:ln/>
+        </p:spPr>
+      </p:sp>
+      <p:sp>
+        <p:nvSpPr>
+          <p:cNvPr id="6" name="Text 4"/>
+          <p:cNvSpPr/>
+          <p:nvPr/>
+        </p:nvSpPr>
+        <p:spPr>
+          <a:xfrm>
+            <a:off x="1097280" y="2496312"/>
+            <a:ext cx="10424160" cy="868680"/>
+          </a:xfrm>
+          <a:prstGeom prst="rect">
+            <a:avLst/>
+          </a:prstGeom>
+          <a:noFill/>
+          <a:ln/>
+        </p:spPr>
+        <p:txBody>
+          <a:bodyPr wrap="square" rtlCol="0" anchor="ctr"/>
+          <a:lstStyle/>
+          <a:p>
+            <a:pPr indent="0" marL="0">
+              <a:buNone/>
+            </a:pPr>
+            <a:r>
+              <a:rPr lang="en-US" sz="1800" dirty="0">
+                <a:solidFill>
+                  <a:srgbClr val="333333"/>
+                </a:solidFill>
+                <a:latin typeface="Aptos" pitchFamily="34" charset="0"/>
+                <a:ea typeface="Aptos" pitchFamily="34" charset="-122"/>
+                <a:cs typeface="Aptos" pitchFamily="34" charset="-120"/>
+              </a:rPr>
+              <a:t>Treat single-map patch-level prioritization for large spending with caution; field-verify before acquisition</a:t>
+            </a:r>
+            <a:endParaRPr lang="en-US" sz="1800" dirty="0"/>
+          </a:p>
+        </p:txBody>
+      </p:sp>
+      <p:sp>
+        <p:nvSpPr>
+          <p:cNvPr id="7" name="Shape 5"/>
+          <p:cNvSpPr/>
+          <p:nvPr/>
+        </p:nvSpPr>
+        <p:spPr>
+          <a:xfrm>
+            <a:off x="731520" y="3730752"/>
+            <a:ext cx="146304" cy="146304"/>
+          </a:xfrm>
+          <a:prstGeom prst="rect">
+            <a:avLst/>
+          </a:prstGeom>
+          <a:solidFill>
+            <a:srgbClr val="C5A55A"/>
+          </a:solidFill>
+          <a:ln/>
+        </p:spPr>
+      </p:sp>
+      <p:sp>
+        <p:nvSpPr>
+          <p:cNvPr id="8" name="Text 6"/>
+          <p:cNvSpPr/>
+          <p:nvPr/>
+        </p:nvSpPr>
+        <p:spPr>
+          <a:xfrm>
+            <a:off x="1097280" y="3547872"/>
+            <a:ext cx="10424160" cy="868680"/>
+          </a:xfrm>
+          <a:prstGeom prst="rect">
+            <a:avLst/>
+          </a:prstGeom>
+          <a:noFill/>
+          <a:ln/>
+        </p:spPr>
+        <p:txBody>
+          <a:bodyPr wrap="square" rtlCol="0" anchor="ctr"/>
+          <a:lstStyle/>
+          <a:p>
+            <a:pPr indent="0" marL="0">
+              <a:buNone/>
+            </a:pPr>
+            <a:r>
+              <a:rPr lang="en-US" sz="1800" dirty="0">
+                <a:solidFill>
+                  <a:srgbClr val="333333"/>
+                </a:solidFill>
+                <a:latin typeface="Aptos" pitchFamily="34" charset="0"/>
+                <a:ea typeface="Aptos" pitchFamily="34" charset="-122"/>
+                <a:cs typeface="Aptos" pitchFamily="34" charset="-120"/>
+              </a:rPr>
+              <a:t>Anchor the mappable definition in FIA field structure (v5.1) with GEDI height as predictor — most defensible, still one estimate</a:t>
+            </a:r>
+            <a:endParaRPr lang="en-US" sz="1800" dirty="0"/>
+          </a:p>
+        </p:txBody>
+      </p:sp>
+      <p:sp>
+        <p:nvSpPr>
+          <p:cNvPr id="9" name="Shape 7"/>
+          <p:cNvSpPr/>
+          <p:nvPr/>
+        </p:nvSpPr>
+        <p:spPr>
+          <a:xfrm>
+            <a:off x="731520" y="4782312"/>
+            <a:ext cx="146304" cy="146304"/>
+          </a:xfrm>
+          <a:prstGeom prst="rect">
+            <a:avLst/>
+          </a:prstGeom>
+          <a:solidFill>
+            <a:srgbClr val="C5A55A"/>
+          </a:solidFill>
+          <a:ln/>
+        </p:spPr>
+      </p:sp>
+      <p:sp>
+        <p:nvSpPr>
+          <p:cNvPr id="10" name="Text 8"/>
+          <p:cNvSpPr/>
+          <p:nvPr/>
+        </p:nvSpPr>
+        <p:spPr>
+          <a:xfrm>
+            <a:off x="1097280" y="4599432"/>
+            <a:ext cx="10424160" cy="868680"/>
+          </a:xfrm>
+          <a:prstGeom prst="rect">
+            <a:avLst/>
+          </a:prstGeom>
+          <a:noFill/>
+          <a:ln/>
+        </p:spPr>
+        <p:txBody>
+          <a:bodyPr wrap="square" rtlCol="0" anchor="ctr"/>
+          <a:lstStyle/>
+          <a:p>
+            <a:pPr indent="0" marL="0">
+              <a:buNone/>
+            </a:pPr>
+            <a:r>
+              <a:rPr lang="en-US" sz="1800" dirty="0">
+                <a:solidFill>
+                  <a:srgbClr val="333333"/>
+                </a:solidFill>
+                <a:latin typeface="Aptos" pitchFamily="34" charset="0"/>
+                <a:ea typeface="Aptos" pitchFamily="34" charset="-122"/>
+                <a:cs typeface="Aptos" pitchFamily="34" charset="-120"/>
+              </a:rPr>
+              <a:t>Reports informing LD 1529 should carry the mapping uncertainty in the headline, not the appendix</a:t>
+            </a:r>
+            <a:endParaRPr lang="en-US" sz="1800" dirty="0"/>
+          </a:p>
+        </p:txBody>
+      </p:sp>
+      <p:sp>
+        <p:nvSpPr>
+          <p:cNvPr id="11" name="Shape 9"/>
+          <p:cNvSpPr/>
+          <p:nvPr/>
+        </p:nvSpPr>
+        <p:spPr>
+          <a:xfrm>
+            <a:off x="0" y="6263640"/>
+            <a:ext cx="12188952" cy="594360"/>
+          </a:xfrm>
+          <a:prstGeom prst="rect">
+            <a:avLst/>
+          </a:prstGeom>
+          <a:solidFill>
+            <a:srgbClr val="1A3D28"/>
+          </a:solidFill>
+          <a:ln/>
+        </p:spPr>
+      </p:sp>
+      <p:sp>
+        <p:nvSpPr>
+          <p:cNvPr id="12" name="Text 10"/>
+          <p:cNvSpPr/>
+          <p:nvPr/>
+        </p:nvSpPr>
+        <p:spPr>
+          <a:xfrm>
+            <a:off x="457200" y="6263640"/>
+            <a:ext cx="11247120" cy="594360"/>
+          </a:xfrm>
+          <a:prstGeom prst="rect">
+            <a:avLst/>
+          </a:prstGeom>
+          <a:noFill/>
+          <a:ln/>
+        </p:spPr>
+        <p:txBody>
+          <a:bodyPr wrap="square" rtlCol="0" anchor="ctr"/>
+          <a:lstStyle/>
+          <a:p>
+            <a:pPr indent="0" marL="0">
+              <a:buNone/>
+            </a:pPr>
+            <a:r>
+              <a:rPr lang="en-US" sz="1700" b="1" dirty="0">
+                <a:solidFill>
+                  <a:srgbClr val="FFFFFF"/>
+                </a:solidFill>
+                <a:latin typeface="Aptos" pitchFamily="34" charset="0"/>
+                <a:ea typeface="Aptos" pitchFamily="34" charset="-122"/>
+                <a:cs typeface="Aptos" pitchFamily="34" charset="-120"/>
+              </a:rPr>
+              <a:t>Use the maps as uncertain guidance, not as precise spending blueprints</a:t>
+            </a:r>
+            <a:endParaRPr lang="en-US" sz="1700" dirty="0"/>
+          </a:p>
+        </p:txBody>
+      </p:sp>
+    </p:spTree>
+  </p:cSld>
+  <p:clrMapOvr>
+    <a:masterClrMapping/>
+  </p:clrMapOvr>
+</p:sld>
+</file>
+
+<file path=ppt/slides/slide13.xml><?xml version="1.0" encoding="utf-8"?>
+<p:sld xmlns:a="http://schemas.openxmlformats.org/drawingml/2006/main" xmlns:r="http://schemas.openxmlformats.org/officeDocument/2006/relationships" xmlns:p="http://schemas.openxmlformats.org/presentationml/2006/main">
+  <p:cSld name="Slide 13">
     <p:bg>
       <p:bgPr>
         <a:solidFill>
@@ -4633,22 +5425,46 @@
                 <a:ea typeface="Aptos Display" pitchFamily="34" charset="-122"/>
                 <a:cs typeface="Aptos Display" pitchFamily="34" charset="-120"/>
               </a:rPr>
-              <a:t>This is real disagreement, not a reproduction error</a:t>
+              <a:t>Is LSOG really “rapidly disappearing”?</a:t>
             </a:r>
             <a:endParaRPr lang="en-US" sz="2900" dirty="0"/>
           </a:p>
         </p:txBody>
       </p:sp>
-      <p:sp>
-        <p:nvSpPr>
-          <p:cNvPr id="3" name="Text 1"/>
-          <p:cNvSpPr/>
-          <p:nvPr/>
-        </p:nvSpPr>
-        <p:spPr>
-          <a:xfrm>
-            <a:off x="914400" y="2194560"/>
-            <a:ext cx="3291840" cy="914400"/>
+      <p:pic>
+        <p:nvPicPr>
+          <p:cNvPr id="3" name="Image 0" descr="figs/u_trend.png">    </p:cNvPr>
+          <p:cNvPicPr>
+            <a:picLocks noChangeAspect="1"/>
+          </p:cNvPicPr>
+          <p:nvPr/>
+        </p:nvPicPr>
+        <p:blipFill>
+          <a:blip r:embed="rId1"/>
+          <a:stretch>
+            <a:fillRect/>
+          </a:stretch>
+        </p:blipFill>
+        <p:spPr>
+          <a:xfrm>
+            <a:off x="1280160" y="1371600"/>
+            <a:ext cx="7498080" cy="4297680"/>
+          </a:xfrm>
+          <a:prstGeom prst="rect">
+            <a:avLst/>
+          </a:prstGeom>
+        </p:spPr>
+      </p:pic>
+      <p:sp>
+        <p:nvSpPr>
+          <p:cNvPr id="4" name="Text 1"/>
+          <p:cNvSpPr/>
+          <p:nvPr/>
+        </p:nvSpPr>
+        <p:spPr>
+          <a:xfrm>
+            <a:off x="9052560" y="1737360"/>
+            <a:ext cx="2743200" cy="3474720"/>
           </a:xfrm>
           <a:prstGeom prst="rect">
             <a:avLst/>
@@ -4660,11 +5476,11 @@
           <a:bodyPr wrap="square" rtlCol="0" anchor="ctr"/>
           <a:lstStyle/>
           <a:p>
-            <a:pPr algn="ctr" indent="0" marL="0">
-              <a:buNone/>
-            </a:pPr>
-            <a:r>
-              <a:rPr lang="en-US" sz="3000" b="1" dirty="0">
+            <a:pPr indent="0" marL="0">
+              <a:buNone/>
+            </a:pPr>
+            <a:r>
+              <a:rPr lang="en-US" sz="4600" b="1" dirty="0">
                 <a:solidFill>
                   <a:srgbClr val="1A3D28"/>
                 </a:solidFill>
@@ -4672,210 +5488,115 @@
                 <a:ea typeface="Aptos Display" pitchFamily="34" charset="-122"/>
                 <a:cs typeface="Aptos Display" pitchFamily="34" charset="-120"/>
               </a:rPr>
-              <a:t>94.2% vs 94.1%</a:t>
-            </a:r>
-            <a:endParaRPr lang="en-US" sz="3000" dirty="0"/>
-          </a:p>
-        </p:txBody>
-      </p:sp>
-      <p:sp>
-        <p:nvSpPr>
-          <p:cNvPr id="4" name="Text 2"/>
-          <p:cNvSpPr/>
-          <p:nvPr/>
-        </p:nvSpPr>
-        <p:spPr>
-          <a:xfrm>
-            <a:off x="914400" y="3200400"/>
-            <a:ext cx="3291840" cy="914400"/>
-          </a:xfrm>
-          <a:prstGeom prst="rect">
-            <a:avLst/>
-          </a:prstGeom>
-          <a:noFill/>
-          <a:ln/>
-        </p:spPr>
-        <p:txBody>
-          <a:bodyPr wrap="square" rtlCol="0" anchor="ctr"/>
-          <a:lstStyle/>
-          <a:p>
-            <a:pPr algn="ctr" indent="0" marL="0">
-              <a:buNone/>
-            </a:pPr>
-            <a:r>
-              <a:rPr lang="en-US" sz="1600" dirty="0">
-                <a:solidFill>
-                  <a:srgbClr val="666666"/>
+              <a:t>No.</a:t>
+            </a:r>
+            <a:pPr indent="0" marL="0">
+              <a:buNone/>
+            </a:pPr>
+            <a:endParaRPr lang="en-US" sz="4600" dirty="0"/>
+          </a:p>
+          <a:p>
+            <a:pPr indent="0" marL="0">
+              <a:buNone/>
+            </a:pPr>
+            <a:r>
+              <a:rPr lang="en-US" sz="1700" dirty="0">
+                <a:solidFill>
+                  <a:srgbClr val="333333"/>
                 </a:solidFill>
                 <a:latin typeface="Aptos" pitchFamily="34" charset="0"/>
                 <a:ea typeface="Aptos" pitchFamily="34" charset="-122"/>
                 <a:cs typeface="Aptos" pitchFamily="34" charset="-120"/>
               </a:rPr>
-              <a:t>we reproduced Hagan’s model exactly</a:t>
-            </a:r>
-            <a:endParaRPr lang="en-US" sz="1600" dirty="0"/>
-          </a:p>
-        </p:txBody>
-      </p:sp>
-      <p:sp>
-        <p:nvSpPr>
-          <p:cNvPr id="5" name="Text 3"/>
-          <p:cNvSpPr/>
-          <p:nvPr/>
-        </p:nvSpPr>
-        <p:spPr>
-          <a:xfrm>
-            <a:off x="4572000" y="2194560"/>
-            <a:ext cx="3291840" cy="914400"/>
-          </a:xfrm>
-          <a:prstGeom prst="rect">
-            <a:avLst/>
-          </a:prstGeom>
-          <a:noFill/>
-          <a:ln/>
-        </p:spPr>
-        <p:txBody>
-          <a:bodyPr wrap="square" rtlCol="0" anchor="ctr"/>
-          <a:lstStyle/>
-          <a:p>
-            <a:pPr algn="ctr" indent="0" marL="0">
-              <a:buNone/>
-            </a:pPr>
-            <a:r>
-              <a:rPr lang="en-US" sz="3000" b="1" dirty="0">
-                <a:solidFill>
-                  <a:srgbClr val="1A3D28"/>
-                </a:solidFill>
-                <a:latin typeface="Aptos Display" pitchFamily="34" charset="0"/>
-                <a:ea typeface="Aptos Display" pitchFamily="34" charset="-122"/>
-                <a:cs typeface="Aptos Display" pitchFamily="34" charset="-120"/>
-              </a:rPr>
-              <a:t>kappa 0.97</a:t>
-            </a:r>
-            <a:endParaRPr lang="en-US" sz="3000" dirty="0"/>
-          </a:p>
-        </p:txBody>
-      </p:sp>
-      <p:sp>
-        <p:nvSpPr>
-          <p:cNvPr id="6" name="Text 4"/>
-          <p:cNvSpPr/>
-          <p:nvPr/>
-        </p:nvSpPr>
-        <p:spPr>
-          <a:xfrm>
-            <a:off x="4572000" y="3200400"/>
-            <a:ext cx="3291840" cy="914400"/>
-          </a:xfrm>
-          <a:prstGeom prst="rect">
-            <a:avLst/>
-          </a:prstGeom>
-          <a:noFill/>
-          <a:ln/>
-        </p:spPr>
-        <p:txBody>
-          <a:bodyPr wrap="square" rtlCol="0" anchor="ctr"/>
-          <a:lstStyle/>
-          <a:p>
-            <a:pPr algn="ctr" indent="0" marL="0">
-              <a:buNone/>
-            </a:pPr>
-            <a:r>
-              <a:rPr lang="en-US" sz="1600" dirty="0">
-                <a:solidFill>
-                  <a:srgbClr val="666666"/>
+              <a:t>TreeMap and FIA both show</a:t>
+            </a:r>
+            <a:endParaRPr lang="en-US" sz="4600" dirty="0"/>
+          </a:p>
+          <a:p>
+            <a:pPr indent="0" marL="0">
+              <a:buNone/>
+            </a:pPr>
+            <a:r>
+              <a:rPr lang="en-US" sz="1700" dirty="0">
+                <a:solidFill>
+                  <a:srgbClr val="333333"/>
                 </a:solidFill>
                 <a:latin typeface="Aptos" pitchFamily="34" charset="0"/>
                 <a:ea typeface="Aptos" pitchFamily="34" charset="-122"/>
                 <a:cs typeface="Aptos" pitchFamily="34" charset="-120"/>
               </a:rPr>
-              <a:t>Seven Islands raster equals the published model</a:t>
-            </a:r>
-            <a:endParaRPr lang="en-US" sz="1600" dirty="0"/>
-          </a:p>
-        </p:txBody>
-      </p:sp>
-      <p:sp>
-        <p:nvSpPr>
-          <p:cNvPr id="7" name="Text 5"/>
-          <p:cNvSpPr/>
-          <p:nvPr/>
-        </p:nvSpPr>
-        <p:spPr>
-          <a:xfrm>
-            <a:off x="8229600" y="2194560"/>
-            <a:ext cx="3291840" cy="914400"/>
-          </a:xfrm>
-          <a:prstGeom prst="rect">
-            <a:avLst/>
-          </a:prstGeom>
-          <a:noFill/>
-          <a:ln/>
-        </p:spPr>
-        <p:txBody>
-          <a:bodyPr wrap="square" rtlCol="0" anchor="ctr"/>
-          <a:lstStyle/>
-          <a:p>
-            <a:pPr algn="ctr" indent="0" marL="0">
-              <a:buNone/>
-            </a:pPr>
-            <a:r>
-              <a:rPr lang="en-US" sz="3000" b="1" dirty="0">
-                <a:solidFill>
-                  <a:srgbClr val="1A3D28"/>
-                </a:solidFill>
-                <a:latin typeface="Aptos Display" pitchFamily="34" charset="0"/>
-                <a:ea typeface="Aptos Display" pitchFamily="34" charset="-122"/>
-                <a:cs typeface="Aptos Display" pitchFamily="34" charset="-120"/>
-              </a:rPr>
-              <a:t>robust</a:t>
-            </a:r>
-            <a:endParaRPr lang="en-US" sz="3000" dirty="0"/>
-          </a:p>
-        </p:txBody>
-      </p:sp>
-      <p:sp>
-        <p:nvSpPr>
-          <p:cNvPr id="8" name="Text 6"/>
-          <p:cNvSpPr/>
-          <p:nvPr/>
-        </p:nvSpPr>
-        <p:spPr>
-          <a:xfrm>
-            <a:off x="8229600" y="3200400"/>
-            <a:ext cx="3291840" cy="914400"/>
-          </a:xfrm>
-          <a:prstGeom prst="rect">
-            <a:avLst/>
-          </a:prstGeom>
-          <a:noFill/>
-          <a:ln/>
-        </p:spPr>
-        <p:txBody>
-          <a:bodyPr wrap="square" rtlCol="0" anchor="ctr"/>
-          <a:lstStyle/>
-          <a:p>
-            <a:pPr algn="ctr" indent="0" marL="0">
-              <a:buNone/>
-            </a:pPr>
-            <a:r>
-              <a:rPr lang="en-US" sz="1600" dirty="0">
-                <a:solidFill>
-                  <a:srgbClr val="666666"/>
+              <a:t>the LSOG stock rising</a:t>
+            </a:r>
+            <a:endParaRPr lang="en-US" sz="4600" dirty="0"/>
+          </a:p>
+          <a:p>
+            <a:pPr indent="0" marL="0">
+              <a:buNone/>
+            </a:pPr>
+            <a:r>
+              <a:rPr lang="en-US" sz="1700" dirty="0">
+                <a:solidFill>
+                  <a:srgbClr val="333333"/>
                 </a:solidFill>
                 <a:latin typeface="Aptos" pitchFamily="34" charset="0"/>
                 <a:ea typeface="Aptos" pitchFamily="34" charset="-122"/>
                 <a:cs typeface="Aptos" pitchFamily="34" charset="-120"/>
               </a:rPr>
-              <a:t>20-seed, fuzz, and bootstrap checks all hold</a:t>
-            </a:r>
-            <a:endParaRPr lang="en-US" sz="1600" dirty="0"/>
-          </a:p>
-        </p:txBody>
-      </p:sp>
-      <p:sp>
-        <p:nvSpPr>
-          <p:cNvPr id="9" name="Shape 7"/>
+              <a:t>(+2.4 to +3.2%/yr)</a:t>
+            </a:r>
+            <a:endParaRPr lang="en-US" sz="4600" dirty="0"/>
+          </a:p>
+          <a:p>
+            <a:pPr indent="0" marL="0">
+              <a:buNone/>
+            </a:pPr>
+            <a:endParaRPr lang="en-US" sz="4600" dirty="0"/>
+          </a:p>
+          <a:p>
+            <a:pPr indent="0" marL="0">
+              <a:buNone/>
+            </a:pPr>
+            <a:endParaRPr lang="en-US" sz="4600" dirty="0"/>
+          </a:p>
+          <a:p>
+            <a:pPr indent="0" marL="0">
+              <a:buNone/>
+            </a:pPr>
+            <a:r>
+              <a:rPr lang="en-US" sz="1500" dirty="0">
+                <a:solidFill>
+                  <a:srgbClr val="666666"/>
+                </a:solidFill>
+                <a:latin typeface="Aptos" pitchFamily="34" charset="0"/>
+                <a:ea typeface="Aptos" pitchFamily="34" charset="-122"/>
+                <a:cs typeface="Aptos" pitchFamily="34" charset="-120"/>
+              </a:rPr>
+              <a:t>Hagan’s “loss” is harvest</a:t>
+            </a:r>
+            <a:endParaRPr lang="en-US" sz="4600" dirty="0"/>
+          </a:p>
+          <a:p>
+            <a:pPr indent="0" marL="0">
+              <a:buNone/>
+            </a:pPr>
+            <a:r>
+              <a:rPr lang="en-US" sz="1500" dirty="0">
+                <a:solidFill>
+                  <a:srgbClr val="666666"/>
+                </a:solidFill>
+                <a:latin typeface="Aptos" pitchFamily="34" charset="0"/>
+                <a:ea typeface="Aptos" pitchFamily="34" charset="-122"/>
+                <a:cs typeface="Aptos" pitchFamily="34" charset="-120"/>
+              </a:rPr>
+              <a:t>flux, not net stock.</a:t>
+            </a:r>
+            <a:endParaRPr lang="en-US" sz="4600" dirty="0"/>
+          </a:p>
+        </p:txBody>
+      </p:sp>
+      <p:sp>
+        <p:nvSpPr>
+          <p:cNvPr id="5" name="Shape 2"/>
           <p:cNvSpPr/>
           <p:nvPr/>
         </p:nvSpPr>
@@ -4895,7 +5616,7 @@
       </p:sp>
       <p:sp>
         <p:nvSpPr>
-          <p:cNvPr id="10" name="Text 8"/>
+          <p:cNvPr id="6" name="Text 3"/>
           <p:cNvSpPr/>
           <p:nvPr/>
         </p:nvSpPr>
@@ -4926,7 +5647,7 @@
                 <a:ea typeface="Aptos" pitchFamily="34" charset="-122"/>
                 <a:cs typeface="Aptos" pitchFamily="34" charset="-120"/>
               </a:rPr>
-              <a:t>The divergence reflects genuine methodological differences in defining LSOG</a:t>
+              <a:t>Stands are harvested at ~2%/yr, but total LSOG is not declining — different questions</a:t>
             </a:r>
             <a:endParaRPr lang="en-US" sz="1700" dirty="0"/>
           </a:p>

</xml_diff>